<commit_message>
changed labels, added new data, started working on models
</commit_message>
<xml_diff>
--- a/report/Infineon_PSOC6_Lecture_Project_Status_Template.pptx
+++ b/report/Infineon_PSOC6_Lecture_Project_Status_Template.pptx
@@ -1083,6 +1083,13 @@
           </a:ln>
           <a:effectLst/>
         </p:spPr>
+        <p:txBody>
+          <a:bodyPr/>
+          <a:lstStyle/>
+          <a:p>
+            <a:endParaRPr lang="de-AT"/>
+          </a:p>
+        </p:txBody>
       </p:sp>
       <p:sp>
         <p:nvSpPr>
@@ -20505,7 +20512,7 @@
                   <a:schemeClr val="tx1"/>
                 </a:solidFill>
               </a:rPr>
-              <a:t>Convert the model and load it  onto the PSOC6 board.</a:t>
+              <a:t>Convert the model and load it onto the PSOC6 board.</a:t>
             </a:r>
           </a:p>
           <a:p>
@@ -21177,8 +21184,123 @@
                   <a:schemeClr val="tx1"/>
                 </a:solidFill>
               </a:rPr>
-              <a:t>text</a:t>
-            </a:r>
+              <a:t>Design and print of newer holder</a:t>
+            </a:r>
+          </a:p>
+          <a:p>
+            <a:pPr marL="285750" indent="-285750" defTabSz="576000" eaLnBrk="0" hangingPunct="0">
+              <a:lnSpc>
+                <a:spcPct val="120000"/>
+              </a:lnSpc>
+              <a:buFont typeface="Arial" panose="020B0604020202020204" pitchFamily="34" charset="0"/>
+              <a:buChar char="•"/>
+            </a:pPr>
+            <a:r>
+              <a:rPr lang="en-US" dirty="0">
+                <a:solidFill>
+                  <a:schemeClr val="tx1"/>
+                </a:solidFill>
+              </a:rPr>
+              <a:t>Acquisition of more training data</a:t>
+            </a:r>
+          </a:p>
+          <a:p>
+            <a:pPr marL="285750" indent="-285750" defTabSz="576000" eaLnBrk="0" hangingPunct="0">
+              <a:lnSpc>
+                <a:spcPct val="120000"/>
+              </a:lnSpc>
+              <a:buFont typeface="Arial" panose="020B0604020202020204" pitchFamily="34" charset="0"/>
+              <a:buChar char="•"/>
+            </a:pPr>
+            <a:r>
+              <a:rPr lang="en-US" dirty="0">
+                <a:solidFill>
+                  <a:schemeClr val="tx1"/>
+                </a:solidFill>
+              </a:rPr>
+              <a:t>Reassessment of the labeling</a:t>
+            </a:r>
+          </a:p>
+          <a:p>
+            <a:pPr marL="285750" indent="-285750" defTabSz="576000" eaLnBrk="0" hangingPunct="0">
+              <a:lnSpc>
+                <a:spcPct val="120000"/>
+              </a:lnSpc>
+              <a:buFont typeface="Arial" panose="020B0604020202020204" pitchFamily="34" charset="0"/>
+              <a:buChar char="•"/>
+            </a:pPr>
+            <a:r>
+              <a:rPr lang="en-US" dirty="0">
+                <a:solidFill>
+                  <a:schemeClr val="tx1"/>
+                </a:solidFill>
+              </a:rPr>
+              <a:t>Training of models with variation in given data</a:t>
+            </a:r>
+          </a:p>
+          <a:p>
+            <a:pPr marL="285750" indent="-285750" defTabSz="576000" eaLnBrk="0" hangingPunct="0">
+              <a:lnSpc>
+                <a:spcPct val="120000"/>
+              </a:lnSpc>
+              <a:buFont typeface="Arial" panose="020B0604020202020204" pitchFamily="34" charset="0"/>
+              <a:buChar char="•"/>
+            </a:pPr>
+            <a:r>
+              <a:rPr lang="en-US" dirty="0">
+                <a:solidFill>
+                  <a:schemeClr val="tx1"/>
+                </a:solidFill>
+              </a:rPr>
+              <a:t>Work on reading the data of the IMU and writing it back via TCP/IP through Tera Term</a:t>
+            </a:r>
+          </a:p>
+          <a:p>
+            <a:pPr marL="285750" indent="-285750" defTabSz="576000" eaLnBrk="0" hangingPunct="0">
+              <a:lnSpc>
+                <a:spcPct val="120000"/>
+              </a:lnSpc>
+              <a:buFont typeface="Arial" panose="020B0604020202020204" pitchFamily="34" charset="0"/>
+              <a:buChar char="•"/>
+            </a:pPr>
+            <a:r>
+              <a:rPr lang="en-US" dirty="0">
+                <a:solidFill>
+                  <a:schemeClr val="tx1"/>
+                </a:solidFill>
+              </a:rPr>
+              <a:t>Work on writing data of each boxing session onto webserver (</a:t>
+            </a:r>
+            <a:r>
+              <a:rPr lang="en-US" dirty="0" err="1">
+                <a:solidFill>
+                  <a:schemeClr val="tx1"/>
+                </a:solidFill>
+              </a:rPr>
+              <a:t>Ubidots</a:t>
+            </a:r>
+            <a:r>
+              <a:rPr lang="en-US" dirty="0">
+                <a:solidFill>
+                  <a:schemeClr val="tx1"/>
+                </a:solidFill>
+              </a:rPr>
+              <a:t>)</a:t>
+            </a:r>
+          </a:p>
+          <a:p>
+            <a:pPr marL="285750" indent="-285750" defTabSz="576000" eaLnBrk="0" hangingPunct="0">
+              <a:lnSpc>
+                <a:spcPct val="120000"/>
+              </a:lnSpc>
+              <a:buFont typeface="Arial" panose="020B0604020202020204" pitchFamily="34" charset="0"/>
+              <a:buChar char="•"/>
+            </a:pPr>
+            <a:endParaRPr lang="en-US" dirty="0">
+              <a:solidFill>
+                <a:schemeClr val="tx1"/>
+              </a:solidFill>
+            </a:endParaRPr>
           </a:p>
         </p:txBody>
       </p:sp>
@@ -21260,8 +21382,99 @@
                   <a:schemeClr val="tx1"/>
                 </a:solidFill>
               </a:rPr>
-              <a:t>text</a:t>
-            </a:r>
+              <a:t>Read out of maximum velocity and current punch through Tera Term</a:t>
+            </a:r>
+          </a:p>
+          <a:p>
+            <a:pPr marL="285750" indent="-285750" defTabSz="576000" eaLnBrk="0" hangingPunct="0">
+              <a:lnSpc>
+                <a:spcPct val="120000"/>
+              </a:lnSpc>
+              <a:buFont typeface="Arial" panose="020B0604020202020204" pitchFamily="34" charset="0"/>
+              <a:buChar char="•"/>
+            </a:pPr>
+            <a:r>
+              <a:rPr lang="en-US" dirty="0">
+                <a:solidFill>
+                  <a:schemeClr val="tx1"/>
+                </a:solidFill>
+              </a:rPr>
+              <a:t>Optimizing parameters to achieve highest accuracy </a:t>
+            </a:r>
+          </a:p>
+          <a:p>
+            <a:pPr marL="285750" indent="-285750" defTabSz="576000" eaLnBrk="0" hangingPunct="0">
+              <a:lnSpc>
+                <a:spcPct val="120000"/>
+              </a:lnSpc>
+              <a:buFont typeface="Arial" panose="020B0604020202020204" pitchFamily="34" charset="0"/>
+              <a:buChar char="•"/>
+            </a:pPr>
+            <a:r>
+              <a:rPr lang="en-US" dirty="0">
+                <a:solidFill>
+                  <a:schemeClr val="tx1"/>
+                </a:solidFill>
+              </a:rPr>
+              <a:t>Creating an interactive dashboard for webserver interface </a:t>
+            </a:r>
+          </a:p>
+          <a:p>
+            <a:pPr marL="285750" indent="-285750" defTabSz="576000" eaLnBrk="0" hangingPunct="0">
+              <a:lnSpc>
+                <a:spcPct val="120000"/>
+              </a:lnSpc>
+              <a:buFont typeface="Arial" panose="020B0604020202020204" pitchFamily="34" charset="0"/>
+              <a:buChar char="•"/>
+            </a:pPr>
+            <a:r>
+              <a:rPr lang="en-US" dirty="0">
+                <a:solidFill>
+                  <a:schemeClr val="tx1"/>
+                </a:solidFill>
+              </a:rPr>
+              <a:t>Implementing the model in micro python into Thonny</a:t>
+            </a:r>
+          </a:p>
+          <a:p>
+            <a:pPr marL="285750" indent="-285750" defTabSz="576000" eaLnBrk="0" hangingPunct="0">
+              <a:lnSpc>
+                <a:spcPct val="120000"/>
+              </a:lnSpc>
+              <a:buFont typeface="Arial" panose="020B0604020202020204" pitchFamily="34" charset="0"/>
+              <a:buChar char="•"/>
+            </a:pPr>
+            <a:endParaRPr lang="en-US" dirty="0">
+              <a:solidFill>
+                <a:schemeClr val="tx1"/>
+              </a:solidFill>
+            </a:endParaRPr>
+          </a:p>
+          <a:p>
+            <a:pPr defTabSz="576000" eaLnBrk="0" hangingPunct="0">
+              <a:lnSpc>
+                <a:spcPct val="120000"/>
+              </a:lnSpc>
+            </a:pPr>
+            <a:endParaRPr lang="en-US" dirty="0">
+              <a:solidFill>
+                <a:schemeClr val="tx1"/>
+              </a:solidFill>
+            </a:endParaRPr>
+          </a:p>
+          <a:p>
+            <a:pPr marL="285750" indent="-285750" defTabSz="576000" eaLnBrk="0" hangingPunct="0">
+              <a:lnSpc>
+                <a:spcPct val="120000"/>
+              </a:lnSpc>
+              <a:buFont typeface="Arial" panose="020B0604020202020204" pitchFamily="34" charset="0"/>
+              <a:buChar char="•"/>
+            </a:pPr>
+            <a:endParaRPr lang="en-US" dirty="0">
+              <a:solidFill>
+                <a:schemeClr val="tx1"/>
+              </a:solidFill>
+            </a:endParaRPr>
           </a:p>
         </p:txBody>
       </p:sp>
@@ -21279,7 +21492,7 @@
         </p:nvSpPr>
         <p:spPr bwMode="auto">
           <a:xfrm>
-            <a:off x="8184232" y="1340690"/>
+            <a:off x="8195487" y="1342350"/>
             <a:ext cx="3671832" cy="5041060"/>
           </a:xfrm>
           <a:prstGeom prst="roundRect">
@@ -21343,8 +21556,90 @@
                   <a:schemeClr val="tx1"/>
                 </a:solidFill>
               </a:rPr>
-              <a:t>text</a:t>
-            </a:r>
+              <a:t>Battery ran out of power</a:t>
+            </a:r>
+          </a:p>
+          <a:p>
+            <a:pPr marL="285750" indent="-285750" defTabSz="576000" eaLnBrk="0" hangingPunct="0">
+              <a:lnSpc>
+                <a:spcPct val="120000"/>
+              </a:lnSpc>
+              <a:buFont typeface="Arial" panose="020B0604020202020204" pitchFamily="34" charset="0"/>
+              <a:buChar char="•"/>
+            </a:pPr>
+            <a:r>
+              <a:rPr lang="en-US" dirty="0">
+                <a:solidFill>
+                  <a:schemeClr val="tx1"/>
+                </a:solidFill>
+              </a:rPr>
+              <a:t>Models' accuracy did not reach desired levels (Question if Labels are not set right or data is not enough…)</a:t>
+            </a:r>
+          </a:p>
+          <a:p>
+            <a:pPr marL="285750" indent="-285750" defTabSz="576000" eaLnBrk="0" hangingPunct="0">
+              <a:lnSpc>
+                <a:spcPct val="120000"/>
+              </a:lnSpc>
+              <a:buFont typeface="Arial" panose="020B0604020202020204" pitchFamily="34" charset="0"/>
+              <a:buChar char="•"/>
+            </a:pPr>
+            <a:r>
+              <a:rPr lang="en-US" dirty="0">
+                <a:solidFill>
+                  <a:schemeClr val="tx1"/>
+                </a:solidFill>
+              </a:rPr>
+              <a:t>Changed names of sessions afterwards which lead to DeepCraft not finding/ having problems with the files</a:t>
+            </a:r>
+          </a:p>
+          <a:p>
+            <a:pPr marL="285750" indent="-285750" defTabSz="576000" eaLnBrk="0" hangingPunct="0">
+              <a:lnSpc>
+                <a:spcPct val="120000"/>
+              </a:lnSpc>
+              <a:buFont typeface="Arial" panose="020B0604020202020204" pitchFamily="34" charset="0"/>
+              <a:buChar char="•"/>
+            </a:pPr>
+            <a:r>
+              <a:rPr lang="en-US" dirty="0">
+                <a:solidFill>
+                  <a:schemeClr val="tx1"/>
+                </a:solidFill>
+              </a:rPr>
+              <a:t>Purpose of preprocessor track</a:t>
+            </a:r>
+          </a:p>
+          <a:p>
+            <a:pPr marL="285750" indent="-285750" defTabSz="576000" eaLnBrk="0" hangingPunct="0">
+              <a:lnSpc>
+                <a:spcPct val="120000"/>
+              </a:lnSpc>
+              <a:buFont typeface="Arial" panose="020B0604020202020204" pitchFamily="34" charset="0"/>
+              <a:buChar char="•"/>
+            </a:pPr>
+            <a:r>
+              <a:rPr lang="en-US" dirty="0">
+                <a:solidFill>
+                  <a:schemeClr val="tx1"/>
+                </a:solidFill>
+              </a:rPr>
+              <a:t>Reading the data out of the IMU only possible for a restricted time</a:t>
+            </a:r>
+          </a:p>
+          <a:p>
+            <a:pPr marL="285750" indent="-285750" defTabSz="576000" eaLnBrk="0" hangingPunct="0">
+              <a:lnSpc>
+                <a:spcPct val="120000"/>
+              </a:lnSpc>
+              <a:buFont typeface="Arial" panose="020B0604020202020204" pitchFamily="34" charset="0"/>
+              <a:buChar char="•"/>
+            </a:pPr>
+            <a:endParaRPr lang="en-US" dirty="0">
+              <a:solidFill>
+                <a:schemeClr val="tx1"/>
+              </a:solidFill>
+            </a:endParaRPr>
           </a:p>
         </p:txBody>
       </p:sp>

</xml_diff>

<commit_message>
added photo to presentation
</commit_message>
<xml_diff>
--- a/report/Infineon_PSOC6_Lecture_Project_Status_Template.pptx
+++ b/report/Infineon_PSOC6_Lecture_Project_Status_Template.pptx
@@ -5,22 +5,23 @@
     <p:sldMasterId id="2147483715" r:id="rId4"/>
   </p:sldMasterIdLst>
   <p:notesMasterIdLst>
-    <p:notesMasterId r:id="rId10"/>
+    <p:notesMasterId r:id="rId11"/>
   </p:notesMasterIdLst>
   <p:handoutMasterIdLst>
-    <p:handoutMasterId r:id="rId11"/>
+    <p:handoutMasterId r:id="rId12"/>
   </p:handoutMasterIdLst>
   <p:sldIdLst>
     <p:sldId id="2147471886" r:id="rId5"/>
     <p:sldId id="2147483465" r:id="rId6"/>
     <p:sldId id="2147483462" r:id="rId7"/>
-    <p:sldId id="2147483464" r:id="rId8"/>
-    <p:sldId id="2147471884" r:id="rId9"/>
+    <p:sldId id="2147483466" r:id="rId8"/>
+    <p:sldId id="2147483464" r:id="rId9"/>
+    <p:sldId id="2147471884" r:id="rId10"/>
   </p:sldIdLst>
   <p:sldSz cx="12192000" cy="6858000"/>
   <p:notesSz cx="7099300" cy="10234613"/>
   <p:custDataLst>
-    <p:tags r:id="rId12"/>
+    <p:tags r:id="rId13"/>
   </p:custDataLst>
   <p:defaultTextStyle>
     <a:defPPr>
@@ -21807,6 +21808,167 @@
         <p:cNvPr id="1" name="">
           <a:extLst>
             <a:ext uri="{FF2B5EF4-FFF2-40B4-BE49-F238E27FC236}">
+              <a16:creationId xmlns:a16="http://schemas.microsoft.com/office/drawing/2014/main" id="{AD5C61B7-1909-A520-4F33-6BAFD7A5706C}"/>
+            </a:ext>
+          </a:extLst>
+        </p:cNvPr>
+        <p:cNvGrpSpPr/>
+        <p:nvPr/>
+      </p:nvGrpSpPr>
+      <p:grpSpPr>
+        <a:xfrm>
+          <a:off x="0" y="0"/>
+          <a:ext cx="0" cy="0"/>
+          <a:chOff x="0" y="0"/>
+          <a:chExt cx="0" cy="0"/>
+        </a:xfrm>
+      </p:grpSpPr>
+      <p:sp>
+        <p:nvSpPr>
+          <p:cNvPr id="3" name="Titel 2">
+            <a:extLst>
+              <a:ext uri="{FF2B5EF4-FFF2-40B4-BE49-F238E27FC236}">
+                <a16:creationId xmlns:a16="http://schemas.microsoft.com/office/drawing/2014/main" id="{F2C27337-A2EC-704C-3006-C37B918B77AC}"/>
+              </a:ext>
+            </a:extLst>
+          </p:cNvPr>
+          <p:cNvSpPr>
+            <a:spLocks noGrp="1"/>
+          </p:cNvSpPr>
+          <p:nvPr>
+            <p:ph type="title"/>
+          </p:nvPr>
+        </p:nvSpPr>
+        <p:spPr/>
+        <p:txBody>
+          <a:bodyPr/>
+          <a:lstStyle/>
+          <a:p>
+            <a:r>
+              <a:rPr lang="de-AT" dirty="0"/>
+              <a:t>Progress-</a:t>
+            </a:r>
+            <a:r>
+              <a:rPr lang="de-AT" dirty="0" err="1"/>
+              <a:t>Documentation</a:t>
+            </a:r>
+            <a:endParaRPr lang="de-AT" dirty="0"/>
+          </a:p>
+        </p:txBody>
+      </p:sp>
+      <p:sp>
+        <p:nvSpPr>
+          <p:cNvPr id="4" name="Datumsplatzhalter 3">
+            <a:extLst>
+              <a:ext uri="{FF2B5EF4-FFF2-40B4-BE49-F238E27FC236}">
+                <a16:creationId xmlns:a16="http://schemas.microsoft.com/office/drawing/2014/main" id="{11DBEEB2-B543-C493-BB15-20B436223EC5}"/>
+              </a:ext>
+            </a:extLst>
+          </p:cNvPr>
+          <p:cNvSpPr>
+            <a:spLocks noGrp="1"/>
+          </p:cNvSpPr>
+          <p:nvPr>
+            <p:ph type="dt" sz="half" idx="14"/>
+          </p:nvPr>
+        </p:nvSpPr>
+        <p:spPr/>
+        <p:txBody>
+          <a:bodyPr/>
+          <a:lstStyle/>
+          <a:p>
+            <a:r>
+              <a:rPr lang="en-US" b="1"/>
+              <a:t> </a:t>
+            </a:r>
+            <a:endParaRPr lang="en-US" b="1" dirty="0"/>
+          </a:p>
+        </p:txBody>
+      </p:sp>
+      <p:sp>
+        <p:nvSpPr>
+          <p:cNvPr id="5" name="Fußzeilenplatzhalter 4">
+            <a:extLst>
+              <a:ext uri="{FF2B5EF4-FFF2-40B4-BE49-F238E27FC236}">
+                <a16:creationId xmlns:a16="http://schemas.microsoft.com/office/drawing/2014/main" id="{1DEAF800-3722-C681-9E42-B2886DD8570D}"/>
+              </a:ext>
+            </a:extLst>
+          </p:cNvPr>
+          <p:cNvSpPr>
+            <a:spLocks noGrp="1"/>
+          </p:cNvSpPr>
+          <p:nvPr>
+            <p:ph type="ftr" sz="quarter" idx="15"/>
+          </p:nvPr>
+        </p:nvSpPr>
+        <p:spPr/>
+        <p:txBody>
+          <a:bodyPr/>
+          <a:lstStyle/>
+          <a:p>
+            <a:endParaRPr lang="en-US" dirty="0"/>
+          </a:p>
+        </p:txBody>
+      </p:sp>
+      <p:pic>
+        <p:nvPicPr>
+          <p:cNvPr id="10" name="Inhaltsplatzhalter 9" descr="Ein Bild, das Text, Software, Computersymbol, Zahl enthält.&#10;&#10;KI-generierte Inhalte können fehlerhaft sein.">
+            <a:extLst>
+              <a:ext uri="{FF2B5EF4-FFF2-40B4-BE49-F238E27FC236}">
+                <a16:creationId xmlns:a16="http://schemas.microsoft.com/office/drawing/2014/main" id="{73187ACD-0C6E-53AA-A317-A2CCD9434D21}"/>
+              </a:ext>
+            </a:extLst>
+          </p:cNvPr>
+          <p:cNvPicPr>
+            <a:picLocks noGrp="1" noChangeAspect="1"/>
+          </p:cNvPicPr>
+          <p:nvPr>
+            <p:ph sz="quarter" idx="13"/>
+          </p:nvPr>
+        </p:nvPicPr>
+        <p:blipFill>
+          <a:blip r:embed="rId2">
+            <a:extLst>
+              <a:ext uri="{28A0092B-C50C-407E-A947-70E740481C1C}">
+                <a14:useLocalDpi xmlns:a14="http://schemas.microsoft.com/office/drawing/2010/main" val="0"/>
+              </a:ext>
+            </a:extLst>
+          </a:blip>
+          <a:stretch>
+            <a:fillRect/>
+          </a:stretch>
+        </p:blipFill>
+        <p:spPr>
+          <a:xfrm>
+            <a:off x="839416" y="1268413"/>
+            <a:ext cx="10343033" cy="5113337"/>
+          </a:xfrm>
+          <a:prstGeom prst="rect">
+            <a:avLst/>
+          </a:prstGeom>
+        </p:spPr>
+      </p:pic>
+    </p:spTree>
+    <p:extLst>
+      <p:ext uri="{BB962C8B-B14F-4D97-AF65-F5344CB8AC3E}">
+        <p14:creationId xmlns:p14="http://schemas.microsoft.com/office/powerpoint/2010/main" val="2479169817"/>
+      </p:ext>
+    </p:extLst>
+  </p:cSld>
+  <p:clrMapOvr>
+    <a:masterClrMapping/>
+  </p:clrMapOvr>
+</p:sld>
+</file>
+
+<file path=ppt/slides/slide5.xml><?xml version="1.0" encoding="utf-8"?>
+<p:sld xmlns:a="http://schemas.openxmlformats.org/drawingml/2006/main" xmlns:r="http://schemas.openxmlformats.org/officeDocument/2006/relationships" xmlns:p="http://schemas.openxmlformats.org/presentationml/2006/main">
+  <p:cSld>
+    <p:spTree>
+      <p:nvGrpSpPr>
+        <p:cNvPr id="1" name="">
+          <a:extLst>
+            <a:ext uri="{FF2B5EF4-FFF2-40B4-BE49-F238E27FC236}">
               <a16:creationId xmlns:a16="http://schemas.microsoft.com/office/drawing/2014/main" id="{FFE580DE-651B-773A-CEE6-5168AC529125}"/>
             </a:ext>
           </a:extLst>
@@ -22306,7 +22468,7 @@
 </p:sld>
 </file>
 
-<file path=ppt/slides/slide5.xml><?xml version="1.0" encoding="utf-8"?>
+<file path=ppt/slides/slide6.xml><?xml version="1.0" encoding="utf-8"?>
 <p:sld xmlns:a="http://schemas.openxmlformats.org/drawingml/2006/main" xmlns:r="http://schemas.openxmlformats.org/officeDocument/2006/relationships" xmlns:p="http://schemas.openxmlformats.org/presentationml/2006/main">
   <p:cSld>
     <p:spTree>
@@ -24618,24 +24780,6 @@
 </file>
 
 <file path=customXml/item1.xml><?xml version="1.0" encoding="utf-8"?>
-<p:properties xmlns:p="http://schemas.microsoft.com/office/2006/metadata/properties" xmlns:xsi="http://www.w3.org/2001/XMLSchema-instance" xmlns:pc="http://schemas.microsoft.com/office/infopath/2007/PartnerControls">
-  <documentManagement>
-    <_ip_UnifiedCompliancePolicyUIAction xmlns="http://schemas.microsoft.com/sharepoint/v3" xsi:nil="true"/>
-    <_ip_UnifiedCompliancePolicyProperties xmlns="http://schemas.microsoft.com/sharepoint/v3" xsi:nil="true"/>
-  </documentManagement>
-</p:properties>
-</file>
-
-<file path=customXml/item2.xml><?xml version="1.0" encoding="utf-8"?>
-<?mso-contentType ?>
-<FormTemplates xmlns="http://schemas.microsoft.com/sharepoint/v3/contenttype/forms">
-  <Display>DocumentLibraryForm</Display>
-  <Edit>DocumentLibraryForm</Edit>
-  <New>DocumentLibraryForm</New>
-</FormTemplates>
-</file>
-
-<file path=customXml/item3.xml><?xml version="1.0" encoding="utf-8"?>
 <ct:contentTypeSchema xmlns:ct="http://schemas.microsoft.com/office/2006/metadata/contentType" xmlns:ma="http://schemas.microsoft.com/office/2006/metadata/properties/metaAttributes" ct:_="" ma:_="" ma:contentTypeName="Document" ma:contentTypeID="0x010100B7908744A1DC0E459D19409169BD101C" ma:contentTypeVersion="10" ma:contentTypeDescription="Create a new document." ma:contentTypeScope="" ma:versionID="d0a38bccec903cc7fc917c43126213b1">
   <xsd:schema xmlns:xsd="http://www.w3.org/2001/XMLSchema" xmlns:xs="http://www.w3.org/2001/XMLSchema" xmlns:p="http://schemas.microsoft.com/office/2006/metadata/properties" xmlns:ns1="http://schemas.microsoft.com/sharepoint/v3" xmlns:ns2="3df75a81-b7cb-4783-ab8b-190cb7919186" targetNamespace="http://schemas.microsoft.com/office/2006/metadata/properties" ma:root="true" ma:fieldsID="18817bea9ddb899bcb71e34dfb063dcd" ns1:_="" ns2:_="">
     <xsd:import namespace="http://schemas.microsoft.com/sharepoint/v3"/>
@@ -24822,32 +24966,25 @@
 </ct:contentTypeSchema>
 </file>
 
-<file path=customXml/itemProps1.xml><?xml version="1.0" encoding="utf-8"?>
-<ds:datastoreItem xmlns:ds="http://schemas.openxmlformats.org/officeDocument/2006/customXml" ds:itemID="{D299A1D5-F553-4264-9022-E0136C61CE27}">
-  <ds:schemaRefs>
-    <ds:schemaRef ds:uri="http://schemas.microsoft.com/office/infopath/2007/PartnerControls"/>
-    <ds:schemaRef ds:uri="3df75a81-b7cb-4783-ab8b-190cb7919186"/>
-    <ds:schemaRef ds:uri="http://purl.org/dc/elements/1.1/"/>
-    <ds:schemaRef ds:uri="http://schemas.microsoft.com/office/2006/documentManagement/types"/>
-    <ds:schemaRef ds:uri="http://schemas.microsoft.com/sharepoint/v3"/>
-    <ds:schemaRef ds:uri="http://schemas.openxmlformats.org/package/2006/metadata/core-properties"/>
-    <ds:schemaRef ds:uri="http://schemas.microsoft.com/office/2006/metadata/properties"/>
-    <ds:schemaRef ds:uri="http://www.w3.org/XML/1998/namespace"/>
-    <ds:schemaRef ds:uri="http://purl.org/dc/dcmitype/"/>
-    <ds:schemaRef ds:uri="http://purl.org/dc/terms/"/>
-  </ds:schemaRefs>
-</ds:datastoreItem>
+<file path=customXml/item2.xml><?xml version="1.0" encoding="utf-8"?>
+<?mso-contentType ?>
+<FormTemplates xmlns="http://schemas.microsoft.com/sharepoint/v3/contenttype/forms">
+  <Display>DocumentLibraryForm</Display>
+  <Edit>DocumentLibraryForm</Edit>
+  <New>DocumentLibraryForm</New>
+</FormTemplates>
 </file>
 
-<file path=customXml/itemProps2.xml><?xml version="1.0" encoding="utf-8"?>
-<ds:datastoreItem xmlns:ds="http://schemas.openxmlformats.org/officeDocument/2006/customXml" ds:itemID="{63C6748B-B74E-4BE1-834C-AEBB9BCA18FB}">
-  <ds:schemaRefs>
-    <ds:schemaRef ds:uri="http://schemas.microsoft.com/sharepoint/v3/contenttype/forms"/>
-  </ds:schemaRefs>
-</ds:datastoreItem>
+<file path=customXml/item3.xml><?xml version="1.0" encoding="utf-8"?>
+<p:properties xmlns:p="http://schemas.microsoft.com/office/2006/metadata/properties" xmlns:xsi="http://www.w3.org/2001/XMLSchema-instance" xmlns:pc="http://schemas.microsoft.com/office/infopath/2007/PartnerControls">
+  <documentManagement>
+    <_ip_UnifiedCompliancePolicyUIAction xmlns="http://schemas.microsoft.com/sharepoint/v3" xsi:nil="true"/>
+    <_ip_UnifiedCompliancePolicyProperties xmlns="http://schemas.microsoft.com/sharepoint/v3" xsi:nil="true"/>
+  </documentManagement>
+</p:properties>
 </file>
 
-<file path=customXml/itemProps3.xml><?xml version="1.0" encoding="utf-8"?>
+<file path=customXml/itemProps1.xml><?xml version="1.0" encoding="utf-8"?>
 <ds:datastoreItem xmlns:ds="http://schemas.openxmlformats.org/officeDocument/2006/customXml" ds:itemID="{E9E621A0-1E67-4A33-AC30-1B8333BDE18B}">
   <ds:schemaRefs>
     <ds:schemaRef ds:uri="http://schemas.microsoft.com/office/2006/metadata/contentType"/>
@@ -24866,6 +25003,31 @@
 </ds:datastoreItem>
 </file>
 
+<file path=customXml/itemProps2.xml><?xml version="1.0" encoding="utf-8"?>
+<ds:datastoreItem xmlns:ds="http://schemas.openxmlformats.org/officeDocument/2006/customXml" ds:itemID="{63C6748B-B74E-4BE1-834C-AEBB9BCA18FB}">
+  <ds:schemaRefs>
+    <ds:schemaRef ds:uri="http://schemas.microsoft.com/sharepoint/v3/contenttype/forms"/>
+  </ds:schemaRefs>
+</ds:datastoreItem>
+</file>
+
+<file path=customXml/itemProps3.xml><?xml version="1.0" encoding="utf-8"?>
+<ds:datastoreItem xmlns:ds="http://schemas.openxmlformats.org/officeDocument/2006/customXml" ds:itemID="{D299A1D5-F553-4264-9022-E0136C61CE27}">
+  <ds:schemaRefs>
+    <ds:schemaRef ds:uri="http://schemas.microsoft.com/office/infopath/2007/PartnerControls"/>
+    <ds:schemaRef ds:uri="3df75a81-b7cb-4783-ab8b-190cb7919186"/>
+    <ds:schemaRef ds:uri="http://purl.org/dc/elements/1.1/"/>
+    <ds:schemaRef ds:uri="http://schemas.microsoft.com/office/2006/documentManagement/types"/>
+    <ds:schemaRef ds:uri="http://schemas.microsoft.com/sharepoint/v3"/>
+    <ds:schemaRef ds:uri="http://schemas.openxmlformats.org/package/2006/metadata/core-properties"/>
+    <ds:schemaRef ds:uri="http://schemas.microsoft.com/office/2006/metadata/properties"/>
+    <ds:schemaRef ds:uri="http://www.w3.org/XML/1998/namespace"/>
+    <ds:schemaRef ds:uri="http://purl.org/dc/dcmitype/"/>
+    <ds:schemaRef ds:uri="http://purl.org/dc/terms/"/>
+  </ds:schemaRefs>
+</ds:datastoreItem>
+</file>
+
 <file path=docMetadata/LabelInfo.xml><?xml version="1.0" encoding="utf-8"?>
 <clbl:labelList xmlns:clbl="http://schemas.microsoft.com/office/2020/mipLabelMetadata">
   <clbl:label id="{a15a25aa-e944-415d-b7a7-40f6b9180b6b}" enabled="1" method="Standard" siteId="{eeb8d0e8-3544-41d3-aac6-934c309faf5a}" removed="0"/>

</xml_diff>